<commit_message>
Synchronize L22 slides with starter/solution, and fixed more naming.
</commit_message>
<xml_diff>
--- a/instructor/l22/l22-pad.pptx
+++ b/instructor/l22/l22-pad.pptx
@@ -23,7 +23,7 @@
     <p:sldId id="324" r:id="rId14"/>
     <p:sldId id="319" r:id="rId15"/>
     <p:sldId id="317" r:id="rId16"/>
-    <p:sldId id="318" r:id="rId17"/>
+    <p:sldId id="325" r:id="rId17"/>
     <p:sldId id="320" r:id="rId18"/>
   </p:sldIdLst>
   <p:sldSz cx="12192000" cy="6858000"/>
@@ -225,7 +225,7 @@
           <a:p>
             <a:fld id="{092B9134-588E-5B42-8C9F-617A27048C6A}" type="datetimeFigureOut">
               <a:rPr lang="en-US" smtClean="0"/>
-              <a:t>11/28/25</a:t>
+              <a:t>7/24/26</a:t>
             </a:fld>
             <a:endParaRPr lang="en-US"/>
           </a:p>
@@ -467,7 +467,7 @@
           <a:p>
             <a:fld id="{6901D574-2425-0C44-8C0A-ED186250828B}" type="datetimeFigureOut">
               <a:rPr lang="en-US" smtClean="0"/>
-              <a:t>11/28/25</a:t>
+              <a:t>7/24/26</a:t>
             </a:fld>
             <a:endParaRPr lang="en-US"/>
           </a:p>
@@ -665,7 +665,7 @@
           <a:p>
             <a:fld id="{6901D574-2425-0C44-8C0A-ED186250828B}" type="datetimeFigureOut">
               <a:rPr lang="en-US" smtClean="0"/>
-              <a:t>11/28/25</a:t>
+              <a:t>7/24/26</a:t>
             </a:fld>
             <a:endParaRPr lang="en-US"/>
           </a:p>
@@ -873,7 +873,7 @@
           <a:p>
             <a:fld id="{6901D574-2425-0C44-8C0A-ED186250828B}" type="datetimeFigureOut">
               <a:rPr lang="en-US" smtClean="0"/>
-              <a:t>11/28/25</a:t>
+              <a:t>7/24/26</a:t>
             </a:fld>
             <a:endParaRPr lang="en-US"/>
           </a:p>
@@ -1071,7 +1071,7 @@
           <a:p>
             <a:fld id="{6901D574-2425-0C44-8C0A-ED186250828B}" type="datetimeFigureOut">
               <a:rPr lang="en-US" smtClean="0"/>
-              <a:t>11/28/25</a:t>
+              <a:t>7/24/26</a:t>
             </a:fld>
             <a:endParaRPr lang="en-US"/>
           </a:p>
@@ -1346,7 +1346,7 @@
           <a:p>
             <a:fld id="{6901D574-2425-0C44-8C0A-ED186250828B}" type="datetimeFigureOut">
               <a:rPr lang="en-US" smtClean="0"/>
-              <a:t>11/28/25</a:t>
+              <a:t>7/24/26</a:t>
             </a:fld>
             <a:endParaRPr lang="en-US"/>
           </a:p>
@@ -1611,7 +1611,7 @@
           <a:p>
             <a:fld id="{6901D574-2425-0C44-8C0A-ED186250828B}" type="datetimeFigureOut">
               <a:rPr lang="en-US" smtClean="0"/>
-              <a:t>11/28/25</a:t>
+              <a:t>7/24/26</a:t>
             </a:fld>
             <a:endParaRPr lang="en-US"/>
           </a:p>
@@ -2023,7 +2023,7 @@
           <a:p>
             <a:fld id="{6901D574-2425-0C44-8C0A-ED186250828B}" type="datetimeFigureOut">
               <a:rPr lang="en-US" smtClean="0"/>
-              <a:t>11/28/25</a:t>
+              <a:t>7/24/26</a:t>
             </a:fld>
             <a:endParaRPr lang="en-US"/>
           </a:p>
@@ -2164,7 +2164,7 @@
           <a:p>
             <a:fld id="{6901D574-2425-0C44-8C0A-ED186250828B}" type="datetimeFigureOut">
               <a:rPr lang="en-US" smtClean="0"/>
-              <a:t>11/28/25</a:t>
+              <a:t>7/24/26</a:t>
             </a:fld>
             <a:endParaRPr lang="en-US"/>
           </a:p>
@@ -2277,7 +2277,7 @@
           <a:p>
             <a:fld id="{6901D574-2425-0C44-8C0A-ED186250828B}" type="datetimeFigureOut">
               <a:rPr lang="en-US" smtClean="0"/>
-              <a:t>11/28/25</a:t>
+              <a:t>7/24/26</a:t>
             </a:fld>
             <a:endParaRPr lang="en-US"/>
           </a:p>
@@ -2588,7 +2588,7 @@
           <a:p>
             <a:fld id="{6901D574-2425-0C44-8C0A-ED186250828B}" type="datetimeFigureOut">
               <a:rPr lang="en-US" smtClean="0"/>
-              <a:t>11/28/25</a:t>
+              <a:t>7/24/26</a:t>
             </a:fld>
             <a:endParaRPr lang="en-US"/>
           </a:p>
@@ -2876,7 +2876,7 @@
           <a:p>
             <a:fld id="{6901D574-2425-0C44-8C0A-ED186250828B}" type="datetimeFigureOut">
               <a:rPr lang="en-US" smtClean="0"/>
-              <a:t>11/28/25</a:t>
+              <a:t>7/24/26</a:t>
             </a:fld>
             <a:endParaRPr lang="en-US"/>
           </a:p>
@@ -3117,7 +3117,7 @@
           <a:p>
             <a:fld id="{6901D574-2425-0C44-8C0A-ED186250828B}" type="datetimeFigureOut">
               <a:rPr lang="en-US" smtClean="0"/>
-              <a:t>11/28/25</a:t>
+              <a:t>7/24/26</a:t>
             </a:fld>
             <a:endParaRPr lang="en-US"/>
           </a:p>
@@ -3626,10 +3626,10 @@
       </p:grpSpPr>
       <p:pic>
         <p:nvPicPr>
-          <p:cNvPr id="3" name="Picture 2">
+          <p:cNvPr id="2" name="Picture 1">
             <a:extLst>
               <a:ext uri="{FF2B5EF4-FFF2-40B4-BE49-F238E27FC236}">
-                <a16:creationId xmlns:a16="http://schemas.microsoft.com/office/drawing/2014/main" id="{96B184B6-840A-3A63-6999-6B205678FC46}"/>
+                <a16:creationId xmlns:a16="http://schemas.microsoft.com/office/drawing/2014/main" id="{491E4FF8-3CCE-0971-76CD-C279716BBE25}"/>
               </a:ext>
             </a:extLst>
           </p:cNvPr>
@@ -3646,8 +3646,8 @@
         </p:blipFill>
         <p:spPr>
           <a:xfrm>
-            <a:off x="2209800" y="1232452"/>
-            <a:ext cx="7772400" cy="5017996"/>
+            <a:off x="2209800" y="792787"/>
+            <a:ext cx="7772400" cy="5272425"/>
           </a:xfrm>
           <a:prstGeom prst="rect">
             <a:avLst/>
@@ -8740,7 +8740,13 @@
   <p:cSld>
     <p:spTree>
       <p:nvGrpSpPr>
-        <p:cNvPr id="1" name=""/>
+        <p:cNvPr id="1" name="">
+          <a:extLst>
+            <a:ext uri="{FF2B5EF4-FFF2-40B4-BE49-F238E27FC236}">
+              <a16:creationId xmlns:a16="http://schemas.microsoft.com/office/drawing/2014/main" id="{4A02C828-2DDF-6975-7B9F-36D9B0EC67A1}"/>
+            </a:ext>
+          </a:extLst>
+        </p:cNvPr>
         <p:cNvGrpSpPr/>
         <p:nvPr/>
       </p:nvGrpSpPr>
@@ -8754,10 +8760,10 @@
       </p:grpSpPr>
       <p:pic>
         <p:nvPicPr>
-          <p:cNvPr id="6" name="Picture 5">
+          <p:cNvPr id="3" name="Picture 2">
             <a:extLst>
               <a:ext uri="{FF2B5EF4-FFF2-40B4-BE49-F238E27FC236}">
-                <a16:creationId xmlns:a16="http://schemas.microsoft.com/office/drawing/2014/main" id="{5E731C75-3870-8851-80E3-B49677959226}"/>
+                <a16:creationId xmlns:a16="http://schemas.microsoft.com/office/drawing/2014/main" id="{F962E288-A678-87D5-307C-EA27C690A08F}"/>
               </a:ext>
             </a:extLst>
           </p:cNvPr>
@@ -8775,7 +8781,7 @@
         <p:spPr>
           <a:xfrm>
             <a:off x="2209800" y="1138696"/>
-            <a:ext cx="7772400" cy="4181215"/>
+            <a:ext cx="7772400" cy="3968464"/>
           </a:xfrm>
           <a:prstGeom prst="rect">
             <a:avLst/>
@@ -8785,7 +8791,7 @@
     </p:spTree>
     <p:extLst>
       <p:ext uri="{BB962C8B-B14F-4D97-AF65-F5344CB8AC3E}">
-        <p14:creationId xmlns:p14="http://schemas.microsoft.com/office/powerpoint/2010/main" val="128928708"/>
+        <p14:creationId xmlns:p14="http://schemas.microsoft.com/office/powerpoint/2010/main" val="2053510951"/>
       </p:ext>
     </p:extLst>
   </p:cSld>
@@ -8814,10 +8820,10 @@
       </p:grpSpPr>
       <p:pic>
         <p:nvPicPr>
-          <p:cNvPr id="6" name="Picture 5">
+          <p:cNvPr id="2" name="Picture 1">
             <a:extLst>
               <a:ext uri="{FF2B5EF4-FFF2-40B4-BE49-F238E27FC236}">
-                <a16:creationId xmlns:a16="http://schemas.microsoft.com/office/drawing/2014/main" id="{02C85F83-E349-B049-6F3B-D381F3030196}"/>
+                <a16:creationId xmlns:a16="http://schemas.microsoft.com/office/drawing/2014/main" id="{8629A430-A055-8E98-39A1-110F42606988}"/>
               </a:ext>
             </a:extLst>
           </p:cNvPr>
@@ -8834,8 +8840,8 @@
         </p:blipFill>
         <p:spPr>
           <a:xfrm>
-            <a:off x="2326328" y="0"/>
-            <a:ext cx="7236505" cy="6858000"/>
+            <a:off x="2209800" y="79088"/>
+            <a:ext cx="7772400" cy="6699823"/>
           </a:xfrm>
           <a:prstGeom prst="rect">
             <a:avLst/>
@@ -17240,10 +17246,10 @@
       </p:grpSpPr>
       <p:pic>
         <p:nvPicPr>
-          <p:cNvPr id="6" name="Picture 5">
+          <p:cNvPr id="3" name="Picture 2">
             <a:extLst>
               <a:ext uri="{FF2B5EF4-FFF2-40B4-BE49-F238E27FC236}">
-                <a16:creationId xmlns:a16="http://schemas.microsoft.com/office/drawing/2014/main" id="{5E731C75-3870-8851-80E3-B49677959226}"/>
+                <a16:creationId xmlns:a16="http://schemas.microsoft.com/office/drawing/2014/main" id="{F40F0F32-1CB8-1950-902E-427F84CEC582}"/>
               </a:ext>
             </a:extLst>
           </p:cNvPr>
@@ -17261,7 +17267,7 @@
         <p:spPr>
           <a:xfrm>
             <a:off x="2209800" y="1138696"/>
-            <a:ext cx="7772400" cy="4181215"/>
+            <a:ext cx="7772400" cy="3968464"/>
           </a:xfrm>
           <a:prstGeom prst="rect">
             <a:avLst/>

</xml_diff>